<commit_message>
Dien thong tin nhom 2
</commit_message>
<xml_diff>
--- a/NOP_BAI/02_SLIDE_THUYET_TRINH.pptx
+++ b/NOP_BAI/02_SLIDE_THUYET_TRINH.pptx
@@ -14599,8 +14599,8 @@
         </p:nvSpPr>
         <p:spPr>
           <a:xfrm>
-            <a:off x="0" y="3246120"/>
-            <a:ext cx="5852160" cy="2651760"/>
+            <a:off x="0" y="3108960"/>
+            <a:ext cx="5120640" cy="3108960"/>
           </a:xfrm>
           <a:prstGeom prst="rect">
             <a:avLst/>
@@ -14667,12 +14667,12 @@
                 <a:spcPct val="95000"/>
               </a:lnSpc>
               <a:spcBef>
-                <a:spcPts val="1400"/>
+                <a:spcPts val="900"/>
               </a:spcBef>
               <a:buNone/>
             </a:pPr>
             <a:r>
-              <a:rPr lang="vi-VN" sz="1600" b="0" i="0" dirty="0">
+              <a:rPr lang="vi-VN" sz="1500" b="0" i="0" dirty="0">
                 <a:solidFill>
                   <a:srgbClr val="262626"/>
                 </a:solidFill>
@@ -14690,12 +14690,12 @@
                 <a:spcPct val="95000"/>
               </a:lnSpc>
               <a:spcBef>
-                <a:spcPts val="300"/>
+                <a:spcPts val="200"/>
               </a:spcBef>
               <a:buNone/>
             </a:pPr>
             <a:r>
-              <a:rPr lang="vi-VN" sz="1600" b="0" i="0" dirty="0">
+              <a:rPr lang="vi-VN" sz="1500" b="0" i="0" dirty="0">
                 <a:solidFill>
                   <a:srgbClr val="262626"/>
                 </a:solidFill>
@@ -14713,12 +14713,12 @@
                 <a:spcPct val="95000"/>
               </a:lnSpc>
               <a:spcBef>
-                <a:spcPts val="300"/>
+                <a:spcPts val="500"/>
               </a:spcBef>
               <a:buNone/>
             </a:pPr>
             <a:r>
-              <a:rPr lang="vi-VN" sz="1600" b="0" i="0" dirty="0">
+              <a:rPr lang="vi-VN" sz="1500" b="1" i="0" dirty="0">
                 <a:solidFill>
                   <a:srgbClr val="262626"/>
                 </a:solidFill>
@@ -14727,7 +14727,99 @@
                 <a:cs typeface="Times New Roman"/>
                 <a:sym typeface="Times New Roman"/>
               </a:rPr>
-              <a:t xml:space="preserve">Nhóm: ……   |   Thành viên: ……………………………………</a:t>
+              <a:t xml:space="preserve">Nhóm 2:</a:t>
+            </a:r>
+          </a:p>
+          <a:p>
+            <a:pPr marL="0" indent="0" algn="l">
+              <a:lnSpc>
+                <a:spcPct val="95000"/>
+              </a:lnSpc>
+              <a:spcBef>
+                <a:spcPts val="100"/>
+              </a:spcBef>
+              <a:buNone/>
+            </a:pPr>
+            <a:r>
+              <a:rPr lang="vi-VN" sz="1400" b="0" i="0" dirty="0">
+                <a:solidFill>
+                  <a:srgbClr val="262626"/>
+                </a:solidFill>
+                <a:latin typeface="Times New Roman"/>
+                <a:ea typeface="Times New Roman"/>
+                <a:cs typeface="Times New Roman"/>
+                <a:sym typeface="Times New Roman"/>
+              </a:rPr>
+              <a:t xml:space="preserve">Nguyễn Quang Tiến – 20261111M</a:t>
+            </a:r>
+          </a:p>
+          <a:p>
+            <a:pPr marL="0" indent="0" algn="l">
+              <a:lnSpc>
+                <a:spcPct val="95000"/>
+              </a:lnSpc>
+              <a:spcBef>
+                <a:spcPts val="0"/>
+              </a:spcBef>
+              <a:buNone/>
+            </a:pPr>
+            <a:r>
+              <a:rPr lang="vi-VN" sz="1400" b="0" i="0" dirty="0">
+                <a:solidFill>
+                  <a:srgbClr val="262626"/>
+                </a:solidFill>
+                <a:latin typeface="Times New Roman"/>
+                <a:ea typeface="Times New Roman"/>
+                <a:cs typeface="Times New Roman"/>
+                <a:sym typeface="Times New Roman"/>
+              </a:rPr>
+              <a:t xml:space="preserve">Hoàng Đức Tư – 20261119M</a:t>
+            </a:r>
+          </a:p>
+          <a:p>
+            <a:pPr marL="0" indent="0" algn="l">
+              <a:lnSpc>
+                <a:spcPct val="95000"/>
+              </a:lnSpc>
+              <a:spcBef>
+                <a:spcPts val="0"/>
+              </a:spcBef>
+              <a:buNone/>
+            </a:pPr>
+            <a:r>
+              <a:rPr lang="vi-VN" sz="1400" b="0" i="0" dirty="0">
+                <a:solidFill>
+                  <a:srgbClr val="262626"/>
+                </a:solidFill>
+                <a:latin typeface="Times New Roman"/>
+                <a:ea typeface="Times New Roman"/>
+                <a:cs typeface="Times New Roman"/>
+                <a:sym typeface="Times New Roman"/>
+              </a:rPr>
+              <a:t xml:space="preserve">Cao Tiến Khải – 20261109M</a:t>
+            </a:r>
+          </a:p>
+          <a:p>
+            <a:pPr marL="0" indent="0" algn="l">
+              <a:lnSpc>
+                <a:spcPct val="95000"/>
+              </a:lnSpc>
+              <a:spcBef>
+                <a:spcPts val="0"/>
+              </a:spcBef>
+              <a:buNone/>
+            </a:pPr>
+            <a:r>
+              <a:rPr lang="vi-VN" sz="1400" b="0" i="0" dirty="0">
+                <a:solidFill>
+                  <a:srgbClr val="262626"/>
+                </a:solidFill>
+                <a:latin typeface="Times New Roman"/>
+                <a:ea typeface="Times New Roman"/>
+                <a:cs typeface="Times New Roman"/>
+                <a:sym typeface="Times New Roman"/>
+              </a:rPr>
+              <a:t xml:space="preserve">Nguyễn Hoàng Quốc – 20261110M</a:t>
             </a:r>
           </a:p>
         </p:txBody>

</xml_diff>

<commit_message>
Them link ma nguon va du lieu
</commit_message>
<xml_diff>
--- a/NOP_BAI/02_SLIDE_THUYET_TRINH.pptx
+++ b/NOP_BAI/02_SLIDE_THUYET_TRINH.pptx
@@ -18005,6 +18005,67 @@
               <a:t xml:space="preserve"> baseline trượt cho phát hiện bất thường, thêm dữ liệu sự cố/thi công, mô hình học máy dự báo tốc độ</a:t>
             </a:r>
           </a:p>
+          <a:p>
+            <a:pPr marL="0" indent="0" algn="l">
+              <a:lnSpc>
+                <a:spcPct val="95000"/>
+              </a:lnSpc>
+              <a:spcBef>
+                <a:spcPts val="900"/>
+              </a:spcBef>
+              <a:buNone/>
+            </a:pPr>
+            <a:r>
+              <a:rPr lang="vi-VN" sz="1300" b="1" i="0" dirty="0">
+                <a:solidFill>
+                  <a:srgbClr val="262626"/>
+                </a:solidFill>
+                <a:latin typeface="Times New Roman"/>
+                <a:ea typeface="Times New Roman"/>
+                <a:cs typeface="Times New Roman"/>
+                <a:sym typeface="Times New Roman"/>
+              </a:rPr>
+              <a:t xml:space="preserve">Mã nguồn:</a:t>
+            </a:r>
+            <a:r>
+              <a:rPr lang="vi-VN" sz="1300" b="0" i="0" dirty="0">
+                <a:solidFill>
+                  <a:srgbClr val="262626"/>
+                </a:solidFill>
+                <a:latin typeface="Times New Roman"/>
+                <a:ea typeface="Times New Roman"/>
+                <a:cs typeface="Times New Roman"/>
+                <a:sym typeface="Times New Roman"/>
+                <a:hlinkClick r:id="rId3"/>
+              </a:rPr>
+              <a:t xml:space="preserve"> github.com/hoangductudhbk-hub/Big_Data_2026A · </a:t>
+            </a:r>
+            <a:r>
+              <a:rPr lang="vi-VN" sz="1300" b="1" i="0" dirty="0">
+                <a:solidFill>
+                  <a:srgbClr val="262626"/>
+                </a:solidFill>
+                <a:latin typeface="Times New Roman"/>
+                <a:ea typeface="Times New Roman"/>
+                <a:cs typeface="Times New Roman"/>
+                <a:sym typeface="Times New Roman"/>
+              </a:rPr>
+              <a:t xml:space="preserve">Dữ liệu gốc:</a:t>
+            </a:r>
+            <a:r>
+              <a:rPr lang="vi-VN" sz="1300" b="0" i="0" dirty="0">
+                <a:solidFill>
+                  <a:srgbClr val="262626"/>
+                </a:solidFill>
+                <a:latin typeface="Times New Roman"/>
+                <a:ea typeface="Times New Roman"/>
+                <a:cs typeface="Times New Roman"/>
+                <a:sym typeface="Times New Roman"/>
+                <a:hlinkClick r:id="rId4"/>
+              </a:rPr>
+              <a:t xml:space="preserve"> Google Drive – dữ liệu NYC 2024</a:t>
+            </a:r>
+          </a:p>
         </p:txBody>
       </p:sp>
       <p:graphicFrame>
@@ -19020,6 +19081,101 @@
               <a:t>THANK YOU !</a:t>
             </a:r>
             <a:endParaRPr/>
+          </a:p>
+        </p:txBody>
+      </p:sp>
+      <p:sp>
+        <p:nvSpPr>
+          <p:cNvPr id="177" name="TextBox 176"/>
+          <p:cNvSpPr txBox="1"/>
+          <p:nvPr/>
+        </p:nvSpPr>
+        <p:spPr>
+          <a:xfrm>
+            <a:off x="3931920" y="3977639"/>
+            <a:ext cx="5029200" cy="914400"/>
+          </a:xfrm>
+          <a:prstGeom prst="rect">
+            <a:avLst/>
+          </a:prstGeom>
+          <a:noFill/>
+        </p:spPr>
+        <p:txBody>
+          <a:bodyPr wrap="square" anchor="t" lIns="91440" rIns="91440" tIns="45720" bIns="45720">
+            <a:spAutoFit/>
+          </a:bodyPr>
+          <a:lstStyle/>
+          <a:p>
+            <a:pPr marL="0" indent="0" algn="l">
+              <a:lnSpc>
+                <a:spcPct val="95000"/>
+              </a:lnSpc>
+              <a:spcBef>
+                <a:spcPts val="0"/>
+              </a:spcBef>
+              <a:buNone/>
+            </a:pPr>
+            <a:r>
+              <a:rPr lang="vi-VN" sz="1400" b="1" i="0" dirty="0">
+                <a:solidFill>
+                  <a:srgbClr val="262626"/>
+                </a:solidFill>
+                <a:latin typeface="Times New Roman"/>
+                <a:ea typeface="Times New Roman"/>
+                <a:cs typeface="Times New Roman"/>
+                <a:sym typeface="Times New Roman"/>
+              </a:rPr>
+              <a:t xml:space="preserve">Mã nguồn:</a:t>
+            </a:r>
+            <a:r>
+              <a:rPr lang="vi-VN" sz="1400" b="0" i="0" dirty="0">
+                <a:solidFill>
+                  <a:srgbClr val="262626"/>
+                </a:solidFill>
+                <a:latin typeface="Times New Roman"/>
+                <a:ea typeface="Times New Roman"/>
+                <a:cs typeface="Times New Roman"/>
+                <a:sym typeface="Times New Roman"/>
+                <a:hlinkClick r:id="rId3"/>
+              </a:rPr>
+              <a:t xml:space="preserve"> github.com/hoangductudhbk-hub/Big_Data_2026A</a:t>
+            </a:r>
+          </a:p>
+          <a:p>
+            <a:pPr marL="0" indent="0" algn="l">
+              <a:lnSpc>
+                <a:spcPct val="95000"/>
+              </a:lnSpc>
+              <a:spcBef>
+                <a:spcPts val="300"/>
+              </a:spcBef>
+              <a:buNone/>
+            </a:pPr>
+            <a:r>
+              <a:rPr lang="vi-VN" sz="1400" b="1" i="0" dirty="0">
+                <a:solidFill>
+                  <a:srgbClr val="262626"/>
+                </a:solidFill>
+                <a:latin typeface="Times New Roman"/>
+                <a:ea typeface="Times New Roman"/>
+                <a:cs typeface="Times New Roman"/>
+                <a:sym typeface="Times New Roman"/>
+              </a:rPr>
+              <a:t xml:space="preserve">Dữ liệu gốc (1,2 GB):</a:t>
+            </a:r>
+            <a:r>
+              <a:rPr lang="vi-VN" sz="1400" b="0" i="0" dirty="0">
+                <a:solidFill>
+                  <a:srgbClr val="262626"/>
+                </a:solidFill>
+                <a:latin typeface="Times New Roman"/>
+                <a:ea typeface="Times New Roman"/>
+                <a:cs typeface="Times New Roman"/>
+                <a:sym typeface="Times New Roman"/>
+                <a:hlinkClick r:id="rId4"/>
+              </a:rPr>
+              <a:t xml:space="preserve"> Google Drive – dữ liệu NYC 2024</a:t>
+            </a:r>
           </a:p>
         </p:txBody>
       </p:sp>

</xml_diff>